<commit_message>
Web: researcher card, compact hero, monospace account fields; deck points to dcp.dev/projects/trustlayer; package.json; README on the two standalone launchers
Includes Dan's manual edits to web/index.html.

Co-Authored-By: Claude Opus 5.5 <noreply@anthropic.com>
</commit_message>
<xml_diff>
--- a/deck/trustlayer-explainer.pptx
+++ b/deck/trustlayer-explainer.pptx
@@ -122,20 +122,20 @@
   <p:extLst>
     <p:ext uri="{521415D9-36F7-43E2-AB2F-B90AF26B5E84}">
       <p14:sectionLst xmlns:p14="http://schemas.microsoft.com/office/powerpoint/2010/main">
-        <p14:section name="Opening" id="{584221e8-70db-8728-774b-ff17fd1bd1f1}">
+        <p14:section name="Opening" id="{d745e4ab-ae26-7914-2264-54c88c54ce1e}">
           <p14:sldIdLst>
             <p14:sldId id="256"/>
             <p14:sldId id="257"/>
             <p14:sldId id="258"/>
           </p14:sldIdLst>
         </p14:section>
-        <p14:section name="The detector" id="{a8ad4365-3af0-64f1-3495-d89dcef2f1c9}">
+        <p14:section name="The detector" id="{45b6d2a9-ff7c-a172-fae0-f29d384e3b74}">
           <p14:sldIdLst>
             <p14:sldId id="259"/>
             <p14:sldId id="260"/>
           </p14:sldIdLst>
         </p14:section>
-        <p14:section name="What we built" id="{d9d1fcac-751c-ce2b-2953-71562446afa3}">
+        <p14:section name="What we built" id="{c2d6d24a-e69b-16be-013c-207e7be87d36}">
           <p14:sldIdLst>
             <p14:sldId id="261"/>
             <p14:sldId id="262"/>
@@ -144,13 +144,13 @@
             <p14:sldId id="265"/>
           </p14:sldIdLst>
         </p14:section>
-        <p14:section name="What it found" id="{77e59158-91ea-375e-591c-28b1e70a96c8}">
+        <p14:section name="What it found" id="{af52d9a7-9d26-1763-bf33-d195c38c4d6c}">
           <p14:sldIdLst>
             <p14:sldId id="266"/>
             <p14:sldId id="267"/>
           </p14:sldIdLst>
         </p14:section>
-        <p14:section name="Next" id="{4de71c12-52e4-0f84-b47c-cec0aaeef05f}">
+        <p14:section name="Next" id="{c29c5f85-6f93-9e5d-7304-2c07ac38e37b}">
           <p14:sldIdLst>
             <p14:sldId id="268"/>
             <p14:sldId id="269"/>
@@ -1992,7 +1992,7 @@
           <a:p>
             <a:r>
               <a:rPr lang="en-US" dirty="0"/>
-              <a:t>To make this usable without a terminal, we built a web page in the same style as our 3KIDNAS galaxy-fitting page. You paste your DCP API key, choose which compute groups may run the job, drop in your audio files and pick the noise conditions. Deploy sends the job; slices come back one by one with a live log. The results show how many genuine clips stayed genuine and how many fakes were caught under each condition, a verdict per file, and a small timeline per file showing the score of every window. There is also a button that runs the very same work function inside your own browser tab, which is how we test the page without spending credits.
+              <a:t>To make this usable without a terminal, we built a web page, hosted at dcp dot dev slash projects slash trustlayer, in the same style as our 3KIDNAS galaxy-fitting page. You paste your DCP API key, choose which compute groups may run the job, drop in your audio files and pick the noise conditions. Deploy sends the job; slices come back one by one with a live log. The results show how many genuine clips stayed genuine and how many fakes were caught under each condition, a verdict per file, and a small timeline per file showing the score of every window. There is also a button that runs the very same work function inside your own browser tab, which is how we test the page without spending credits.
 [Visual: screen recording of the page. Files are dragged onto the drop zone, the noise checkboxes ticked, Deploy pressed; the progress bar fills as slices return and the results table populates. Zoom in on one timeline.]</a:t>
             </a:r>
             <a:endParaRPr lang="en-US" dirty="0"/>
@@ -2526,7 +2526,7 @@
           <a:p>
             <a:r>
               <a:rPr lang="en-US" dirty="0"/>
-              <a:t>TrustLayer started as a weekend camp project with a sharp question: can this detector be trusted on noisy audio? Running it on DCP turns that question into something you can ask at any scale, with any noise, and soon with stronger models. The page is ready: serve the folder, drop in your audio, pick the conditions, and deploy.
+              <a:t>TrustLayer started as a weekend camp project with a sharp question: can this detector be trusted on noisy audio? Running it on DCP turns that question into something you can ask at any scale, with any noise, and soon with stronger models. The page is live at dcp.dev/projects/trustlayer: open it, drop in your audio, pick the conditions, and deploy.
 [Visual: return to the opening marble surface and the two waveforms. Both play once; the genuine one gets a slate tick, the synthetic one a brick cross. Fade to the title. End card.]</a:t>
             </a:r>
             <a:endParaRPr lang="en-US" dirty="0"/>
@@ -8683,6 +8683,24 @@
         <p:txBody>
           <a:bodyPr wrap="square" lIns="0" tIns="0" rIns="0" bIns="0" rtlCol="0" anchor="t"/>
           <a:lstStyle/>
+          <a:p>
+            <a:pPr marL="342900" indent="-342900">
+              <a:spcAft>
+                <a:spcPts val="600"/>
+              </a:spcAft>
+              <a:buSzPct val="100000"/>
+              <a:buChar char="•"/>
+            </a:pPr>
+            <a:r>
+              <a:rPr lang="en-US" sz="1500" dirty="0">
+                <a:solidFill>
+                  <a:schemeClr val="tx1"/>
+                </a:solidFill>
+              </a:rPr>
+              <a:t>Open dcp.dev/projects/trustlayer. Nothing to install.</a:t>
+            </a:r>
+            <a:endParaRPr lang="en-US" sz="1500" dirty="0"/>
+          </a:p>
           <a:p>
             <a:pPr marL="342900" indent="-342900">
               <a:spcAft>
@@ -13618,7 +13636,7 @@
                   <a:schemeClr val="tx1"/>
                 </a:solidFill>
               </a:rPr>
-              <a:t>Deploy from the web page to the public network, and host it next to our other demos.</a:t>
+              <a:t>Run jobs from dcp.dev/projects/trustlayer on the Queen's compute group and the public network.</a:t>
             </a:r>
             <a:endParaRPr lang="en-US" sz="1500" dirty="0"/>
           </a:p>
@@ -14574,7 +14592,7 @@
                   <a:schemeClr val="tx2"/>
                 </a:solidFill>
               </a:rPr>
-              <a:t>Serve the web folder, drop in some audio, choose your noise levels, deploy.</a:t>
+              <a:t>Open dcp.dev/projects/trustlayer, drop in some audio, choose your noise levels, deploy.</a:t>
             </a:r>
             <a:endParaRPr lang="en-US" sz="2000" dirty="0"/>
           </a:p>

</xml_diff>

<commit_message>
Web: worker QR beside the run log, drop in-browser run; deck and docs updated; deploy command
Co-Authored-By: Claude Opus 5.5 <noreply@anthropic.com>
</commit_message>
<xml_diff>
--- a/deck/trustlayer-explainer.pptx
+++ b/deck/trustlayer-explainer.pptx
@@ -122,20 +122,20 @@
   <p:extLst>
     <p:ext uri="{521415D9-36F7-43E2-AB2F-B90AF26B5E84}">
       <p14:sectionLst xmlns:p14="http://schemas.microsoft.com/office/powerpoint/2010/main">
-        <p14:section name="Opening" id="{d745e4ab-ae26-7914-2264-54c88c54ce1e}">
+        <p14:section name="Opening" id="{107ba265-6cfa-e07d-5369-59de8f51a89e}">
           <p14:sldIdLst>
             <p14:sldId id="256"/>
             <p14:sldId id="257"/>
             <p14:sldId id="258"/>
           </p14:sldIdLst>
         </p14:section>
-        <p14:section name="The detector" id="{45b6d2a9-ff7c-a172-fae0-f29d384e3b74}">
+        <p14:section name="The detector" id="{834f65d6-c2bb-f446-4897-16e22d8fbf31}">
           <p14:sldIdLst>
             <p14:sldId id="259"/>
             <p14:sldId id="260"/>
           </p14:sldIdLst>
         </p14:section>
-        <p14:section name="What we built" id="{c2d6d24a-e69b-16be-013c-207e7be87d36}">
+        <p14:section name="What we built" id="{37dcc05d-6193-6a3d-af70-6311477af778}">
           <p14:sldIdLst>
             <p14:sldId id="261"/>
             <p14:sldId id="262"/>
@@ -144,13 +144,13 @@
             <p14:sldId id="265"/>
           </p14:sldIdLst>
         </p14:section>
-        <p14:section name="What it found" id="{af52d9a7-9d26-1763-bf33-d195c38c4d6c}">
+        <p14:section name="What it found" id="{97189085-3c22-d8df-89bc-69d6ae18ecde}">
           <p14:sldIdLst>
             <p14:sldId id="266"/>
             <p14:sldId id="267"/>
           </p14:sldIdLst>
         </p14:section>
-        <p14:section name="Next" id="{c29c5f85-6f93-9e5d-7304-2c07ac38e37b}">
+        <p14:section name="Next" id="{8279610e-b824-27f4-96d0-e3dd7103242f}">
           <p14:sldIdLst>
             <p14:sldId id="268"/>
             <p14:sldId id="269"/>
@@ -1992,7 +1992,7 @@
           <a:p>
             <a:r>
               <a:rPr lang="en-US" dirty="0"/>
-              <a:t>To make this usable without a terminal, we built a web page, hosted at dcp dot dev slash projects slash trustlayer, in the same style as our 3KIDNAS galaxy-fitting page. You paste your DCP API key, choose which compute groups may run the job, drop in your audio files and pick the noise conditions. Deploy sends the job; slices come back one by one with a live log. The results show how many genuine clips stayed genuine and how many fakes were caught under each condition, a verdict per file, and a small timeline per file showing the score of every window. There is also a button that runs the very same work function inside your own browser tab, which is how we test the page without spending credits.
+              <a:t>To make this usable without a terminal, we built a web page, hosted at dcp dot dev slash projects slash trustlayer, in the same style as our 3KIDNAS galaxy-fitting page. You paste your DCP API key, choose which compute groups may run the job, drop in your audio files and pick the noise conditions. Deploy sends the job; slices come back one by one with a live log. The results show how many genuine clips stayed genuine and how many fakes were caught under each condition, a verdict per file, and a small timeline per file showing the score of every window. Beside the log there is a QR code: scan it with a phone or open it on a laptop and that device becomes a DCP worker in the same compute group, so anyone in the room can help run the job.
 [Visual: screen recording of the page. Files are dragged onto the drop zone, the noise checkboxes ticked, Deploy pressed; the progress bar fills as slices return and the results table populates. Zoom in on one timeline.]</a:t>
             </a:r>
             <a:endParaRPr lang="en-US" dirty="0"/>
@@ -8805,7 +8805,7 @@
                   <a:schemeClr val="tx1"/>
                 </a:solidFill>
               </a:rPr>
-              <a:t>"Run in this browser" runs the same work function in the tab, to test without spending credits.</a:t>
+              <a:t>A QR code beside the log opens a browser worker in the same compute group, so anyone in the room can help run the job.</a:t>
             </a:r>
             <a:endParaRPr lang="en-US" sz="1500" dirty="0"/>
           </a:p>
@@ -25710,7 +25710,7 @@
                           <a:ea typeface="Calibri" pitchFamily="34" charset="-122"/>
                           <a:cs typeface="Calibri" pitchFamily="34" charset="-120"/>
                         </a:rPr>
-                        <a:t>Chrome tab (web page, "run in this browser")</a:t>
+                        <a:t>Chrome tab (same function, tested in the page)</a:t>
                       </a:r>
                       <a:endParaRPr lang="en-US" sz="1400" dirty="0">
                         <a:latin typeface="Calibri" charset="0"/>

</xml_diff>